<commit_message>
Activité 81 · originalité ramenée de 2,8 % à 0,9 %
Les 212 énoncés visibles du module comparés aux 7 153 des trente-sept autres
modules de build/contenu/ : six identiques au premier relevé, soit 2,8 %.

Quatre ont été reformulés avec les mots du module — deux consignes
génériques, un titre de vrai-ou-faux, une phrase de contenu que
module-n5-logement portait mot pour mot. L'opération est sans risque parce
que ni les `sub` ni les `tit` n'entrent dans le relevé des sons, et la seule
ligne de contenu touchée appartient à un `vf` sans cartes écoutables : le
manifeste des 224 extraits est identique avant et après, vérifié par diff.

Les deux qui restent sont des entrées du lexique du programme — « un quatre
et demie » et « chauffé et éclairé ». Les renommer éloignerait le module de
sa seule source.

Le sommaire des fiches manquait au commit précédent : il y est.

Co-Authored-By: Claude Opus 5 <noreply@anthropic.com>
</commit_message>
<xml_diff>
--- a/assets/powerpoints/module-n3-loyer/B1-chauffe-eclaire-non-meuble.pptx
+++ b/assets/powerpoints/module-n3-loyer/B1-chauffe-eclaire-non-meuble.pptx
@@ -5765,7 +5765,7 @@
                 </a:solidFill>
                 <a:latin typeface="Verdana"/>
               </a:rPr>
-              <a:t>Le logement est libre le premier juillet.   </a:t>
+              <a:t>On peut emménager à partir du premier juillet.   </a:t>
             </a:r>
             <a:r>
               <a:rPr sz="1400" b="1" i="0">
@@ -12621,7 +12621,7 @@
                 </a:solidFill>
                 <a:latin typeface="Verdana"/>
               </a:rPr>
-              <a:t>Le logement est libre le premier juillet.</a:t>
+              <a:t>On peut emménager à partir du premier juillet.</a:t>
             </a:r>
           </a:p>
         </p:txBody>

</xml_diff>